<commit_message>
docs: expand PPTX presentation with agent integration and security architecture slides
</commit_message>
<xml_diff>
--- a/janus_showcase.pptx
+++ b/janus_showcase.pptx
@@ -11,6 +11,8 @@
     <p:sldId id="259" r:id="rId10"/>
     <p:sldId id="260" r:id="rId11"/>
     <p:sldId id="261" r:id="rId12"/>
+    <p:sldId id="262" r:id="rId13"/>
+    <p:sldId id="263" r:id="rId14"/>
   </p:sldIdLst>
   <p:sldSz cx="12188952" cy="6858000" type="screen4x3"/>
   <p:notesSz cx="6858000" cy="9144000"/>
@@ -4722,6 +4724,705 @@
             </a:pPr>
             <a:r>
               <a:t>Figure 6.1: Unified interactive Swagger UI API documentation explorer.</a:t>
+            </a:r>
+          </a:p>
+        </p:txBody>
+      </p:sp>
+    </p:spTree>
+  </p:cSld>
+  <p:clrMapOvr>
+    <a:masterClrMapping/>
+  </p:clrMapOvr>
+</p:sld>
+</file>
+
+<file path=ppt/slides/slide7.xml><?xml version="1.0" encoding="utf-8"?>
+<p:sld xmlns:a="http://schemas.openxmlformats.org/drawingml/2006/main" xmlns:p="http://schemas.openxmlformats.org/presentationml/2006/main" xmlns:r="http://schemas.openxmlformats.org/officeDocument/2006/relationships">
+  <p:cSld>
+    <p:bg>
+      <p:bgPr>
+        <a:solidFill>
+          <a:srgbClr val="181A1B"/>
+        </a:solidFill>
+        <a:effectLst/>
+      </p:bgPr>
+    </p:bg>
+    <p:spTree>
+      <p:nvGrpSpPr>
+        <p:cNvPr id="1" name=""/>
+        <p:cNvGrpSpPr/>
+        <p:nvPr/>
+      </p:nvGrpSpPr>
+      <p:grpSpPr/>
+      <p:sp>
+        <p:nvSpPr>
+          <p:cNvPr id="2" name="TextBox 1"/>
+          <p:cNvSpPr txBox="1"/>
+          <p:nvPr/>
+        </p:nvSpPr>
+        <p:spPr>
+          <a:xfrm>
+            <a:off x="731520" y="274320"/>
+            <a:ext cx="10698480" cy="365760"/>
+          </a:xfrm>
+          <a:prstGeom prst="rect">
+            <a:avLst/>
+          </a:prstGeom>
+          <a:noFill/>
+        </p:spPr>
+        <p:txBody>
+          <a:bodyPr wrap="square">
+            <a:spAutoFit/>
+          </a:bodyPr>
+          <a:lstStyle/>
+          <a:p>
+            <a:pPr>
+              <a:defRPr sz="1000" b="1">
+                <a:solidFill>
+                  <a:srgbClr val="FE8019"/>
+                </a:solidFill>
+                <a:latin typeface="Arial"/>
+              </a:defRPr>
+            </a:pPr>
+            <a:r>
+              <a:t>AGENT CLIENT INTEGRATIONS</a:t>
+            </a:r>
+          </a:p>
+        </p:txBody>
+      </p:sp>
+      <p:sp>
+        <p:nvSpPr>
+          <p:cNvPr id="3" name="TextBox 2"/>
+          <p:cNvSpPr txBox="1"/>
+          <p:nvPr/>
+        </p:nvSpPr>
+        <p:spPr>
+          <a:xfrm>
+            <a:off x="731520" y="548640"/>
+            <a:ext cx="10698480" cy="822960"/>
+          </a:xfrm>
+          <a:prstGeom prst="rect">
+            <a:avLst/>
+          </a:prstGeom>
+          <a:noFill/>
+        </p:spPr>
+        <p:txBody>
+          <a:bodyPr wrap="square">
+            <a:spAutoFit/>
+          </a:bodyPr>
+          <a:lstStyle/>
+          <a:p>
+            <a:pPr>
+              <a:defRPr sz="2800" b="1">
+                <a:solidFill>
+                  <a:srgbClr val="EBDBB2"/>
+                </a:solidFill>
+                <a:latin typeface="Arial"/>
+              </a:defRPr>
+            </a:pPr>
+            <a:r>
+              <a:t>Multi-Agent Client Integrations</a:t>
+            </a:r>
+          </a:p>
+        </p:txBody>
+      </p:sp>
+      <p:sp>
+        <p:nvSpPr>
+          <p:cNvPr id="4" name="TextBox 3"/>
+          <p:cNvSpPr txBox="1"/>
+          <p:nvPr/>
+        </p:nvSpPr>
+        <p:spPr>
+          <a:xfrm>
+            <a:off x="731520" y="1645920"/>
+            <a:ext cx="5120640" cy="4572000"/>
+          </a:xfrm>
+          <a:prstGeom prst="rect">
+            <a:avLst/>
+          </a:prstGeom>
+          <a:noFill/>
+        </p:spPr>
+        <p:txBody>
+          <a:bodyPr wrap="square">
+            <a:spAutoFit/>
+          </a:bodyPr>
+          <a:lstStyle/>
+          <a:p>
+            <a:pPr>
+              <a:spcAft>
+                <a:spcPts val="200"/>
+              </a:spcAft>
+              <a:defRPr sz="1400" b="1">
+                <a:solidFill>
+                  <a:srgbClr val="EBDBB2"/>
+                </a:solidFill>
+                <a:latin typeface="Arial"/>
+              </a:defRPr>
+            </a:pPr>
+            <a:r>
+              <a:t>• Claude &amp; Desktop IDEs (Stdio): </a:t>
+            </a:r>
+          </a:p>
+          <a:p>
+            <a:pPr>
+              <a:spcAft>
+                <a:spcPts val="1200"/>
+              </a:spcAft>
+              <a:defRPr sz="1250">
+                <a:solidFill>
+                  <a:srgbClr val="A89984"/>
+                </a:solidFill>
+                <a:latin typeface="Arial"/>
+              </a:defRPr>
+            </a:pPr>
+            <a:r>
+              <a:t>Claude Desktop, VS Code Copilot extensions, and Codex wrappers connect via the stdin/stdout channel. The local client spawns the Janus binary as a sub-process, passing the authentication token securely in the process environment.</a:t>
+            </a:r>
+          </a:p>
+          <a:p>
+            <a:pPr>
+              <a:spcAft>
+                <a:spcPts val="200"/>
+              </a:spcAft>
+              <a:defRPr sz="1400" b="1">
+                <a:solidFill>
+                  <a:srgbClr val="EBDBB2"/>
+                </a:solidFill>
+                <a:latin typeface="Arial"/>
+              </a:defRPr>
+            </a:pPr>
+            <a:r>
+              <a:t>• Antigravity &amp; Web Agents (SSE): </a:t>
+            </a:r>
+          </a:p>
+          <a:p>
+            <a:pPr>
+              <a:spcAft>
+                <a:spcPts val="1200"/>
+              </a:spcAft>
+              <a:defRPr sz="1250">
+                <a:solidFill>
+                  <a:srgbClr val="A89984"/>
+                </a:solidFill>
+                <a:latin typeface="Arial"/>
+              </a:defRPr>
+            </a:pPr>
+            <a:r>
+              <a:t>Google Antigravity SDK and other server-side agentic frameworks query tools over Server-Sent Events (SSE). The gateway acts as a high-performance SSE streaming server, validating headers on every frame.</a:t>
+            </a:r>
+          </a:p>
+          <a:p>
+            <a:pPr>
+              <a:spcAft>
+                <a:spcPts val="200"/>
+              </a:spcAft>
+              <a:defRPr sz="1400" b="1">
+                <a:solidFill>
+                  <a:srgbClr val="EBDBB2"/>
+                </a:solidFill>
+                <a:latin typeface="Arial"/>
+              </a:defRPr>
+            </a:pPr>
+            <a:r>
+              <a:t>• Dynamic Tool Discovery: </a:t>
+            </a:r>
+          </a:p>
+          <a:p>
+            <a:pPr>
+              <a:spcAft>
+                <a:spcPts val="1200"/>
+              </a:spcAft>
+              <a:defRPr sz="1250">
+                <a:solidFill>
+                  <a:srgbClr val="A89984"/>
+                </a:solidFill>
+                <a:latin typeface="Arial"/>
+              </a:defRPr>
+            </a:pPr>
+            <a:r>
+              <a:t>Regardless of client (Claude, Copilot, or Antigravity), the client automatically queries the `tools/list` endpoint at startup. It dynamically retrieves up-to-date tool schemas without hardcoded mapping updates.</a:t>
+            </a:r>
+          </a:p>
+        </p:txBody>
+      </p:sp>
+      <p:sp>
+        <p:nvSpPr>
+          <p:cNvPr id="5" name="TextBox 4"/>
+          <p:cNvSpPr txBox="1"/>
+          <p:nvPr/>
+        </p:nvSpPr>
+        <p:spPr>
+          <a:xfrm>
+            <a:off x="6217920" y="1645920"/>
+            <a:ext cx="5212080" cy="4114800"/>
+          </a:xfrm>
+          <a:prstGeom prst="rect">
+            <a:avLst/>
+          </a:prstGeom>
+          <a:solidFill>
+            <a:srgbClr val="0F1112"/>
+          </a:solidFill>
+        </p:spPr>
+        <p:txBody>
+          <a:bodyPr wrap="square">
+            <a:spAutoFit/>
+          </a:bodyPr>
+          <a:lstStyle/>
+          <a:p>
+            <a:pPr>
+              <a:spcAft>
+                <a:spcPts val="200"/>
+              </a:spcAft>
+              <a:defRPr sz="1100">
+                <a:solidFill>
+                  <a:srgbClr val="A89984"/>
+                </a:solidFill>
+                <a:latin typeface="Courier New"/>
+              </a:defRPr>
+            </a:pPr>
+            <a:r>
+              <a:t>  // Claude Desktop Integration (claude_desktop_config.json)</a:t>
+            </a:r>
+          </a:p>
+          <a:p>
+            <a:pPr>
+              <a:spcAft>
+                <a:spcPts val="1200"/>
+              </a:spcAft>
+              <a:defRPr sz="1050">
+                <a:solidFill>
+                  <a:srgbClr val="FFFFFF"/>
+                </a:solidFill>
+                <a:latin typeface="Courier New"/>
+              </a:defRPr>
+            </a:pPr>
+            <a:r>
+              <a:t>  {</a:t>
+            </a:r>
+            <a:br/>
+            <a:r>
+              <a:t>    "mcpServers": {</a:t>
+            </a:r>
+            <a:br/>
+            <a:r>
+              <a:t>      "janus-gateway": {</a:t>
+            </a:r>
+            <a:br/>
+            <a:r>
+              <a:t>        "command": "/usr/local/bin/mcp-gateway",</a:t>
+            </a:r>
+            <a:br/>
+            <a:r>
+              <a:t>        "args": ["-stdio"],</a:t>
+            </a:r>
+            <a:br/>
+            <a:r>
+              <a:t>        "env": {</a:t>
+            </a:r>
+            <a:br/>
+            <a:r>
+              <a:t>          "MCP_GATEWAY_TOKEN": "client-bearer-token"</a:t>
+            </a:r>
+            <a:br/>
+            <a:r>
+              <a:t>        }</a:t>
+            </a:r>
+            <a:br/>
+            <a:r>
+              <a:t>      }</a:t>
+            </a:r>
+            <a:br/>
+            <a:r>
+              <a:t>    }</a:t>
+            </a:r>
+            <a:br/>
+            <a:r>
+              <a:t>  }</a:t>
+            </a:r>
+          </a:p>
+          <a:p>
+            <a:pPr>
+              <a:spcAft>
+                <a:spcPts val="200"/>
+              </a:spcAft>
+              <a:defRPr sz="1100">
+                <a:solidFill>
+                  <a:srgbClr val="A89984"/>
+                </a:solidFill>
+                <a:latin typeface="Courier New"/>
+              </a:defRPr>
+            </a:pPr>
+            <a:r>
+              <a:t>  # Antigravity SDK Integration (Python)</a:t>
+            </a:r>
+          </a:p>
+          <a:p>
+            <a:pPr>
+              <a:defRPr sz="1050">
+                <a:solidFill>
+                  <a:srgbClr val="FE8019"/>
+                </a:solidFill>
+                <a:latin typeface="Courier New"/>
+              </a:defRPr>
+            </a:pPr>
+            <a:r>
+              <a:t>  from antigravity_sdk import Agent, ToolRegistry</a:t>
+            </a:r>
+            <a:br/>
+            <a:r>
+              <a:t>  reg = ToolRegistry.from_mcp_sse(</a:t>
+            </a:r>
+            <a:br/>
+            <a:r>
+              <a:t>      url="http://localhost:8899/sse",</a:t>
+            </a:r>
+            <a:br/>
+            <a:r>
+              <a:t>      headers={"Authorization": "Bearer token"}</a:t>
+            </a:r>
+            <a:br/>
+            <a:r>
+              <a:t>  )</a:t>
+            </a:r>
+            <a:br/>
+            <a:r>
+              <a:t>  agent = Agent(tools=reg.list_tools())</a:t>
+            </a:r>
+          </a:p>
+        </p:txBody>
+      </p:sp>
+    </p:spTree>
+  </p:cSld>
+  <p:clrMapOvr>
+    <a:masterClrMapping/>
+  </p:clrMapOvr>
+</p:sld>
+</file>
+
+<file path=ppt/slides/slide8.xml><?xml version="1.0" encoding="utf-8"?>
+<p:sld xmlns:a="http://schemas.openxmlformats.org/drawingml/2006/main" xmlns:p="http://schemas.openxmlformats.org/presentationml/2006/main" xmlns:r="http://schemas.openxmlformats.org/officeDocument/2006/relationships">
+  <p:cSld>
+    <p:bg>
+      <p:bgPr>
+        <a:solidFill>
+          <a:srgbClr val="181A1B"/>
+        </a:solidFill>
+        <a:effectLst/>
+      </p:bgPr>
+    </p:bg>
+    <p:spTree>
+      <p:nvGrpSpPr>
+        <p:cNvPr id="1" name=""/>
+        <p:cNvGrpSpPr/>
+        <p:nvPr/>
+      </p:nvGrpSpPr>
+      <p:grpSpPr/>
+      <p:sp>
+        <p:nvSpPr>
+          <p:cNvPr id="2" name="TextBox 1"/>
+          <p:cNvSpPr txBox="1"/>
+          <p:nvPr/>
+        </p:nvSpPr>
+        <p:spPr>
+          <a:xfrm>
+            <a:off x="731520" y="274320"/>
+            <a:ext cx="10698480" cy="365760"/>
+          </a:xfrm>
+          <a:prstGeom prst="rect">
+            <a:avLst/>
+          </a:prstGeom>
+          <a:noFill/>
+        </p:spPr>
+        <p:txBody>
+          <a:bodyPr wrap="square">
+            <a:spAutoFit/>
+          </a:bodyPr>
+          <a:lstStyle/>
+          <a:p>
+            <a:pPr>
+              <a:defRPr sz="1000" b="1">
+                <a:solidFill>
+                  <a:srgbClr val="FE8019"/>
+                </a:solidFill>
+                <a:latin typeface="Arial"/>
+              </a:defRPr>
+            </a:pPr>
+            <a:r>
+              <a:t>ENTERPRISE SECURITY &amp; CAPABILITIES</a:t>
+            </a:r>
+          </a:p>
+        </p:txBody>
+      </p:sp>
+      <p:sp>
+        <p:nvSpPr>
+          <p:cNvPr id="3" name="TextBox 2"/>
+          <p:cNvSpPr txBox="1"/>
+          <p:nvPr/>
+        </p:nvSpPr>
+        <p:spPr>
+          <a:xfrm>
+            <a:off x="731520" y="548640"/>
+            <a:ext cx="10698480" cy="822960"/>
+          </a:xfrm>
+          <a:prstGeom prst="rect">
+            <a:avLst/>
+          </a:prstGeom>
+          <a:noFill/>
+        </p:spPr>
+        <p:txBody>
+          <a:bodyPr wrap="square">
+            <a:spAutoFit/>
+          </a:bodyPr>
+          <a:lstStyle/>
+          <a:p>
+            <a:pPr>
+              <a:defRPr sz="2800" b="1">
+                <a:solidFill>
+                  <a:srgbClr val="EBDBB2"/>
+                </a:solidFill>
+                <a:latin typeface="Arial"/>
+              </a:defRPr>
+            </a:pPr>
+            <a:r>
+              <a:t>API Security Shield &amp; Enterprise Capabilities</a:t>
+            </a:r>
+          </a:p>
+        </p:txBody>
+      </p:sp>
+      <p:sp>
+        <p:nvSpPr>
+          <p:cNvPr id="4" name="TextBox 3"/>
+          <p:cNvSpPr txBox="1"/>
+          <p:nvPr/>
+        </p:nvSpPr>
+        <p:spPr>
+          <a:xfrm>
+            <a:off x="731520" y="1645920"/>
+            <a:ext cx="5120640" cy="4572000"/>
+          </a:xfrm>
+          <a:prstGeom prst="rect">
+            <a:avLst/>
+          </a:prstGeom>
+          <a:noFill/>
+        </p:spPr>
+        <p:txBody>
+          <a:bodyPr wrap="square">
+            <a:spAutoFit/>
+          </a:bodyPr>
+          <a:lstStyle/>
+          <a:p>
+            <a:pPr>
+              <a:spcAft>
+                <a:spcPts val="200"/>
+              </a:spcAft>
+              <a:defRPr sz="1400" b="1">
+                <a:solidFill>
+                  <a:srgbClr val="EBDBB2"/>
+                </a:solidFill>
+                <a:latin typeface="Arial"/>
+              </a:defRPr>
+            </a:pPr>
+            <a:r>
+              <a:t>• Credential Redaction (Zero-Trust): </a:t>
+            </a:r>
+          </a:p>
+          <a:p>
+            <a:pPr>
+              <a:spcAft>
+                <a:spcPts val="1200"/>
+              </a:spcAft>
+              <a:defRPr sz="1250">
+                <a:solidFill>
+                  <a:srgbClr val="A89984"/>
+                </a:solidFill>
+                <a:latin typeface="Arial"/>
+              </a:defRPr>
+            </a:pPr>
+            <a:r>
+              <a:t>Secrets (API keys, Basic Auth, custom headers) are stored in secure cloud/local vaults (AWS, GCP, Azure, SQLite). The LLM agent only queries references (e.g. prod/stripe/key); the gateway injects secrets at runtime, keeping them hidden from LLM memory.</a:t>
+            </a:r>
+          </a:p>
+          <a:p>
+            <a:pPr>
+              <a:spcAft>
+                <a:spcPts val="200"/>
+              </a:spcAft>
+              <a:defRPr sz="1400" b="1">
+                <a:solidFill>
+                  <a:srgbClr val="EBDBB2"/>
+                </a:solidFill>
+                <a:latin typeface="Arial"/>
+              </a:defRPr>
+            </a:pPr>
+            <a:r>
+              <a:t>• Namespace Prefix Scoping: </a:t>
+            </a:r>
+          </a:p>
+          <a:p>
+            <a:pPr>
+              <a:spcAft>
+                <a:spcPts val="1200"/>
+              </a:spcAft>
+              <a:defRPr sz="1250">
+                <a:solidFill>
+                  <a:srgbClr val="A89984"/>
+                </a:solidFill>
+                <a:latin typeface="Arial"/>
+              </a:defRPr>
+            </a:pPr>
+            <a:r>
+              <a:t>Isolates microservice endpoints behind client token scopes (e.g. stripe_*). Prevents prompt-injection attacks from triggering cross-service commands.</a:t>
+            </a:r>
+          </a:p>
+          <a:p>
+            <a:pPr>
+              <a:spcAft>
+                <a:spcPts val="200"/>
+              </a:spcAft>
+              <a:defRPr sz="1400" b="1">
+                <a:solidFill>
+                  <a:srgbClr val="EBDBB2"/>
+                </a:solidFill>
+                <a:latin typeface="Arial"/>
+              </a:defRPr>
+            </a:pPr>
+            <a:r>
+              <a:t>• Audit &amp; mTLS Enforcement: </a:t>
+            </a:r>
+          </a:p>
+          <a:p>
+            <a:pPr>
+              <a:spcAft>
+                <a:spcPts val="1200"/>
+              </a:spcAft>
+              <a:defRPr sz="1250">
+                <a:solidFill>
+                  <a:srgbClr val="A89984"/>
+                </a:solidFill>
+                <a:latin typeface="Arial"/>
+              </a:defRPr>
+            </a:pPr>
+            <a:r>
+              <a:t>Every transaction is audited for duration, caller identity, and errors. Client-side CA checks enforce Mutual TLS (mTLS) for all incoming SSE traffic.</a:t>
+            </a:r>
+          </a:p>
+        </p:txBody>
+      </p:sp>
+      <p:sp>
+        <p:nvSpPr>
+          <p:cNvPr id="5" name="TextBox 4"/>
+          <p:cNvSpPr txBox="1"/>
+          <p:nvPr/>
+        </p:nvSpPr>
+        <p:spPr>
+          <a:xfrm>
+            <a:off x="6217920" y="1645920"/>
+            <a:ext cx="5120640" cy="4572000"/>
+          </a:xfrm>
+          <a:prstGeom prst="rect">
+            <a:avLst/>
+          </a:prstGeom>
+          <a:noFill/>
+        </p:spPr>
+        <p:txBody>
+          <a:bodyPr wrap="square">
+            <a:spAutoFit/>
+          </a:bodyPr>
+          <a:lstStyle/>
+          <a:p>
+            <a:pPr>
+              <a:spcAft>
+                <a:spcPts val="200"/>
+              </a:spcAft>
+              <a:defRPr sz="1400" b="1">
+                <a:solidFill>
+                  <a:srgbClr val="EBDBB2"/>
+                </a:solidFill>
+                <a:latin typeface="Arial"/>
+              </a:defRPr>
+            </a:pPr>
+            <a:r>
+              <a:t>• Unified API-to-Tool Workspace: </a:t>
+            </a:r>
+          </a:p>
+          <a:p>
+            <a:pPr>
+              <a:spcAft>
+                <a:spcPts val="1200"/>
+              </a:spcAft>
+              <a:defRPr sz="1250">
+                <a:solidFill>
+                  <a:srgbClr val="A89984"/>
+                </a:solidFill>
+                <a:latin typeface="Arial"/>
+              </a:defRPr>
+            </a:pPr>
+            <a:r>
+              <a:t>Exposes all legacy microservices and proprietary REST APIs as standard local capabilities to your developer AI stack.</a:t>
+            </a:r>
+          </a:p>
+          <a:p>
+            <a:pPr>
+              <a:spcAft>
+                <a:spcPts val="200"/>
+              </a:spcAft>
+              <a:defRPr sz="1400" b="1">
+                <a:solidFill>
+                  <a:srgbClr val="EBDBB2"/>
+                </a:solidFill>
+                <a:latin typeface="Arial"/>
+              </a:defRPr>
+            </a:pPr>
+            <a:r>
+              <a:t>• Air-Gapped Operation: </a:t>
+            </a:r>
+          </a:p>
+          <a:p>
+            <a:pPr>
+              <a:spcAft>
+                <a:spcPts val="1200"/>
+              </a:spcAft>
+              <a:defRPr sz="1250">
+                <a:solidFill>
+                  <a:srgbClr val="A89984"/>
+                </a:solidFill>
+                <a:latin typeface="Arial"/>
+              </a:defRPr>
+            </a:pPr>
+            <a:r>
+              <a:t>Enables fully local LLM workflows in offline development terminals with no external telemetry egress.</a:t>
+            </a:r>
+          </a:p>
+          <a:p>
+            <a:pPr>
+              <a:spcAft>
+                <a:spcPts val="200"/>
+              </a:spcAft>
+              <a:defRPr sz="1400" b="1">
+                <a:solidFill>
+                  <a:srgbClr val="EBDBB2"/>
+                </a:solidFill>
+                <a:latin typeface="Arial"/>
+              </a:defRPr>
+            </a:pPr>
+            <a:r>
+              <a:t>• Dynamic Capability Updates: </a:t>
+            </a:r>
+          </a:p>
+          <a:p>
+            <a:pPr>
+              <a:spcAft>
+                <a:spcPts val="1200"/>
+              </a:spcAft>
+              <a:defRPr sz="1250">
+                <a:solidFill>
+                  <a:srgbClr val="A89984"/>
+                </a:solidFill>
+                <a:latin typeface="Arial"/>
+              </a:defRPr>
+            </a:pPr>
+            <a:r>
+              <a:t>Updating an endpoint mapping in the portal instantly exposes the new tool capability to all connected Claude, Copilot, and Antigravity agents without recompilation.</a:t>
             </a:r>
           </a:p>
         </p:txBody>

</xml_diff>